<commit_message>
Built site for gh-pages
</commit_message>
<xml_diff>
--- a/posts/2023/Lifestyle/QuartoBasics.pptx
+++ b/posts/2023/Lifestyle/QuartoBasics.pptx
@@ -3150,8 +3150,6 @@
             <a:pPr lvl="0" indent="0" marL="0">
               <a:buNone/>
             </a:pPr>
-            <a:br/>
-            <a:br/>
             <a:r>
               <a:rPr/>
               <a:t>司馬博文</a:t>
@@ -3402,7 +3400,9 @@
         <p:nvSpPr>
           <p:cNvPr id="1" name="TextBox 3"/>
           <p:cNvSpPr txBox="1"/>
-          <p:nvPr/>
+          <p:nvPr>
+            <p:ph idx="1"/>
+          </p:nvPr>
         </p:nvSpPr>
         <p:spPr>
           <a:xfrm>
@@ -4610,40 +4610,42 @@
                         </m:rPr>
                         <m:t>P</m:t>
                       </m:r>
-                      <m:d>
-                        <m:dPr>
-                          <m:begChr m:val="["/>
-                          <m:sepChr m:val=""/>
-                          <m:endChr m:val="]"/>
-                          <m:grow/>
-                        </m:dPr>
-                        <m:e>
-                          <m:r>
-                            <m:rPr>
-                              <m:sty m:val="p"/>
-                            </m:rPr>
-                            <m:t>|</m:t>
-                          </m:r>
-                          <m:r>
-                            <m:t>ξ</m:t>
-                          </m:r>
-                          <m:r>
-                            <m:rPr>
-                              <m:sty m:val="p"/>
-                            </m:rPr>
-                            <m:t>|</m:t>
-                          </m:r>
-                          <m:r>
-                            <m:rPr>
-                              <m:sty m:val="p"/>
-                            </m:rPr>
-                            <m:t>&lt;</m:t>
-                          </m:r>
-                          <m:r>
-                            <m:t>t</m:t>
-                          </m:r>
-                        </m:e>
-                      </m:d>
+                      <m:r>
+                        <m:rPr>
+                          <m:sty m:val="p"/>
+                        </m:rPr>
+                        <m:t>[</m:t>
+                      </m:r>
+                      <m:r>
+                        <m:rPr>
+                          <m:sty m:val="p"/>
+                        </m:rPr>
+                        <m:t>|</m:t>
+                      </m:r>
+                      <m:r>
+                        <m:t>ξ</m:t>
+                      </m:r>
+                      <m:r>
+                        <m:rPr>
+                          <m:sty m:val="p"/>
+                        </m:rPr>
+                        <m:t>|</m:t>
+                      </m:r>
+                      <m:r>
+                        <m:rPr>
+                          <m:sty m:val="p"/>
+                        </m:rPr>
+                        <m:t>&lt;</m:t>
+                      </m:r>
+                      <m:r>
+                        <m:t>t</m:t>
+                      </m:r>
+                      <m:r>
+                        <m:rPr>
+                          <m:sty m:val="p"/>
+                        </m:rPr>
+                        <m:t>]</m:t>
+                      </m:r>
                       <m:r>
                         <m:rPr>
                           <m:sty m:val="p"/>

</xml_diff>